<commit_message>
Fix template formatting: center review names, bold modules
</commit_message>
<xml_diff>
--- a/assets/weekly_report_template.pptx
+++ b/assets/weekly_report_template.pptx
@@ -4573,7 +4573,7 @@
                   <a:txBody>
                     <a:bodyPr/>
                     <a:p>
-                      <a:pPr marL="0" marR="0" lvl="0" algn="l" defTabSz="914400" rtl="0" eaLnBrk="1" fontAlgn="base" latinLnBrk="0" hangingPunct="1">
+                      <a:pPr marL="0" marR="0" lvl="0" algn="ctr" defTabSz="914400" rtl="0" eaLnBrk="1" fontAlgn="base" latinLnBrk="0" hangingPunct="1">
                         <a:lnSpc>
                           <a:spcPct val="100000"/>
                         </a:lnSpc>
@@ -26018,7 +26018,7 @@
                         <a:buNone/>
                       </a:pPr>
                       <a:r>
-                        <a:rPr sz="1100">
+                        <a:rPr sz="1100" b="1">
                           <a:ea typeface="楷体"/>
                           <a:latin typeface="楷体"/>
                         </a:rPr>

</xml_diff>